<commit_message>
fix(deck): remove duplicate effectLst that triggered PowerPoint repair
Every shadowed card had two <a:effectLst> children: an empty one from
`shadow.inherit = False` plus the one appended by add_shadow(). Two
effectLst elements violate the CT_ShapeProperties schema (maxOccurs=1),
which is what made PowerPoint prompt to repair the file.

add_shadow() now strips any pre-existing effectLst before appending its
own. Validated: 0 of 751 shapes have duplicate spPr children or bad
element ordering; file round-trips and renders cleanly.

Co-Authored-By: Claude Opus 4.8 (1M context) <noreply@anthropic.com>
</commit_message>
<xml_diff>
--- a/Argus_Platform_Deck.pptx
+++ b/Argus_Platform_Deck.pptx
@@ -4345,7 +4345,6 @@
           <a:ln>
             <a:noFill/>
           </a:ln>
-          <a:effectLst/>
           <a:effectLst>
             <a:outerShdw blurRad="95000" dist="38000" dir="5400000" rotWithShape="0">
               <a:srgbClr val="6A00C9">
@@ -4767,7 +4766,6 @@
           <a:ln>
             <a:noFill/>
           </a:ln>
-          <a:effectLst/>
           <a:effectLst>
             <a:outerShdw blurRad="95000" dist="38000" dir="5400000" rotWithShape="0">
               <a:srgbClr val="6A00C9">
@@ -5992,7 +5990,6 @@
           <a:ln>
             <a:noFill/>
           </a:ln>
-          <a:effectLst/>
           <a:effectLst>
             <a:outerShdw blurRad="95000" dist="38000" dir="5400000" rotWithShape="0">
               <a:srgbClr val="6A00C9">
@@ -6376,7 +6373,6 @@
           <a:ln>
             <a:noFill/>
           </a:ln>
-          <a:effectLst/>
           <a:effectLst>
             <a:outerShdw blurRad="95000" dist="38000" dir="5400000" rotWithShape="0">
               <a:srgbClr val="6A00C9">
@@ -6760,7 +6756,6 @@
           <a:ln>
             <a:noFill/>
           </a:ln>
-          <a:effectLst/>
           <a:effectLst>
             <a:outerShdw blurRad="95000" dist="38000" dir="5400000" rotWithShape="0">
               <a:srgbClr val="6A00C9">
@@ -7552,7 +7547,6 @@
           <a:ln>
             <a:noFill/>
           </a:ln>
-          <a:effectLst/>
           <a:effectLst>
             <a:outerShdw blurRad="95000" dist="38000" dir="5400000" rotWithShape="0">
               <a:srgbClr val="6A00C9">
@@ -7804,7 +7798,6 @@
           <a:ln>
             <a:noFill/>
           </a:ln>
-          <a:effectLst/>
           <a:effectLst>
             <a:outerShdw blurRad="95000" dist="38000" dir="5400000" rotWithShape="0">
               <a:srgbClr val="6A00C9">
@@ -7975,7 +7968,6 @@
           <a:ln>
             <a:noFill/>
           </a:ln>
-          <a:effectLst/>
           <a:effectLst>
             <a:outerShdw blurRad="95000" dist="38000" dir="5400000" rotWithShape="0">
               <a:srgbClr val="6A00C9">
@@ -8146,7 +8138,6 @@
           <a:ln>
             <a:noFill/>
           </a:ln>
-          <a:effectLst/>
           <a:effectLst>
             <a:outerShdw blurRad="95000" dist="38000" dir="5400000" rotWithShape="0">
               <a:srgbClr val="6A00C9">
@@ -8317,7 +8308,6 @@
           <a:ln>
             <a:noFill/>
           </a:ln>
-          <a:effectLst/>
           <a:effectLst>
             <a:outerShdw blurRad="95000" dist="38000" dir="5400000" rotWithShape="0">
               <a:srgbClr val="6A00C9">
@@ -8488,7 +8478,6 @@
           <a:ln>
             <a:noFill/>
           </a:ln>
-          <a:effectLst/>
           <a:effectLst>
             <a:outerShdw blurRad="95000" dist="38000" dir="5400000" rotWithShape="0">
               <a:srgbClr val="6A00C9">
@@ -9245,7 +9234,6 @@
           <a:ln>
             <a:noFill/>
           </a:ln>
-          <a:effectLst/>
           <a:effectLst>
             <a:outerShdw blurRad="95000" dist="38000" dir="5400000" rotWithShape="0">
               <a:srgbClr val="6A00C9">
@@ -9451,7 +9439,6 @@
           <a:ln>
             <a:noFill/>
           </a:ln>
-          <a:effectLst/>
           <a:effectLst>
             <a:outerShdw blurRad="95000" dist="38000" dir="5400000" rotWithShape="0">
               <a:srgbClr val="6A00C9">
@@ -9657,7 +9644,6 @@
           <a:ln>
             <a:noFill/>
           </a:ln>
-          <a:effectLst/>
           <a:effectLst>
             <a:outerShdw blurRad="95000" dist="38000" dir="5400000" rotWithShape="0">
               <a:srgbClr val="6A00C9">
@@ -9863,7 +9849,6 @@
           <a:ln>
             <a:noFill/>
           </a:ln>
-          <a:effectLst/>
           <a:effectLst>
             <a:outerShdw blurRad="95000" dist="38000" dir="5400000" rotWithShape="0">
               <a:srgbClr val="6A00C9">
@@ -10069,7 +10054,6 @@
           <a:ln>
             <a:noFill/>
           </a:ln>
-          <a:effectLst/>
           <a:effectLst>
             <a:outerShdw blurRad="95000" dist="38000" dir="5400000" rotWithShape="0">
               <a:srgbClr val="6A00C9">
@@ -11043,7 +11027,6 @@
           <a:ln>
             <a:noFill/>
           </a:ln>
-          <a:effectLst/>
           <a:effectLst>
             <a:outerShdw blurRad="95000" dist="38000" dir="5400000" rotWithShape="0">
               <a:srgbClr val="6A00C9">
@@ -11175,7 +11158,6 @@
           <a:ln>
             <a:noFill/>
           </a:ln>
-          <a:effectLst/>
           <a:effectLst>
             <a:outerShdw blurRad="95000" dist="38000" dir="5400000" rotWithShape="0">
               <a:srgbClr val="6A00C9">
@@ -11307,7 +11289,6 @@
           <a:ln>
             <a:noFill/>
           </a:ln>
-          <a:effectLst/>
           <a:effectLst>
             <a:outerShdw blurRad="95000" dist="38000" dir="5400000" rotWithShape="0">
               <a:srgbClr val="6A00C9">
@@ -11439,7 +11420,6 @@
           <a:ln>
             <a:noFill/>
           </a:ln>
-          <a:effectLst/>
           <a:effectLst>
             <a:outerShdw blurRad="95000" dist="38000" dir="5400000" rotWithShape="0">
               <a:srgbClr val="6A00C9">
@@ -11571,7 +11551,6 @@
           <a:ln>
             <a:noFill/>
           </a:ln>
-          <a:effectLst/>
           <a:effectLst>
             <a:outerShdw blurRad="95000" dist="38000" dir="5400000" rotWithShape="0">
               <a:srgbClr val="6A00C9">
@@ -11703,7 +11682,6 @@
           <a:ln>
             <a:noFill/>
           </a:ln>
-          <a:effectLst/>
           <a:effectLst>
             <a:outerShdw blurRad="95000" dist="38000" dir="5400000" rotWithShape="0">
               <a:srgbClr val="6A00C9">
@@ -11870,7 +11848,6 @@
           <a:ln>
             <a:noFill/>
           </a:ln>
-          <a:effectLst/>
           <a:effectLst>
             <a:outerShdw blurRad="95000" dist="38000" dir="5400000" rotWithShape="0">
               <a:srgbClr val="6A00C9">
@@ -12037,7 +12014,6 @@
           <a:ln>
             <a:noFill/>
           </a:ln>
-          <a:effectLst/>
           <a:effectLst>
             <a:outerShdw blurRad="95000" dist="38000" dir="5400000" rotWithShape="0">
               <a:srgbClr val="6A00C9">
@@ -12204,7 +12180,6 @@
           <a:ln>
             <a:noFill/>
           </a:ln>
-          <a:effectLst/>
           <a:effectLst>
             <a:outerShdw blurRad="95000" dist="38000" dir="5400000" rotWithShape="0">
               <a:srgbClr val="6A00C9">
@@ -12906,7 +12881,6 @@
           <a:ln>
             <a:noFill/>
           </a:ln>
-          <a:effectLst/>
           <a:effectLst>
             <a:outerShdw blurRad="95000" dist="38000" dir="5400000" rotWithShape="0">
               <a:srgbClr val="6A00C9">
@@ -13114,7 +13088,6 @@
           <a:ln>
             <a:noFill/>
           </a:ln>
-          <a:effectLst/>
           <a:effectLst>
             <a:outerShdw blurRad="95000" dist="38000" dir="5400000" rotWithShape="0">
               <a:srgbClr val="6A00C9">
@@ -13322,7 +13295,6 @@
           <a:ln>
             <a:noFill/>
           </a:ln>
-          <a:effectLst/>
           <a:effectLst>
             <a:outerShdw blurRad="95000" dist="38000" dir="5400000" rotWithShape="0">
               <a:srgbClr val="6A00C9">
@@ -13530,7 +13502,6 @@
           <a:ln>
             <a:noFill/>
           </a:ln>
-          <a:effectLst/>
           <a:effectLst>
             <a:outerShdw blurRad="95000" dist="38000" dir="5400000" rotWithShape="0">
               <a:srgbClr val="6A00C9">
@@ -13738,7 +13709,6 @@
           <a:ln>
             <a:noFill/>
           </a:ln>
-          <a:effectLst/>
           <a:effectLst>
             <a:outerShdw blurRad="95000" dist="38000" dir="5400000" rotWithShape="0">
               <a:srgbClr val="6A00C9">
@@ -13946,7 +13916,6 @@
           <a:ln>
             <a:noFill/>
           </a:ln>
-          <a:effectLst/>
           <a:effectLst>
             <a:outerShdw blurRad="95000" dist="38000" dir="5400000" rotWithShape="0">
               <a:srgbClr val="6A00C9">
@@ -14922,7 +14891,6 @@
           <a:ln>
             <a:noFill/>
           </a:ln>
-          <a:effectLst/>
           <a:effectLst>
             <a:outerShdw blurRad="95000" dist="38000" dir="5400000" rotWithShape="0">
               <a:srgbClr val="6A00C9">
@@ -15129,7 +15097,6 @@
           <a:ln>
             <a:noFill/>
           </a:ln>
-          <a:effectLst/>
           <a:effectLst>
             <a:outerShdw blurRad="95000" dist="38000" dir="5400000" rotWithShape="0">
               <a:srgbClr val="6A00C9">
@@ -15337,7 +15304,6 @@
           <a:ln>
             <a:noFill/>
           </a:ln>
-          <a:effectLst/>
           <a:effectLst>
             <a:outerShdw blurRad="95000" dist="38000" dir="5400000" rotWithShape="0">
               <a:srgbClr val="6A00C9">
@@ -15544,7 +15510,6 @@
           <a:ln>
             <a:noFill/>
           </a:ln>
-          <a:effectLst/>
           <a:effectLst>
             <a:outerShdw blurRad="95000" dist="38000" dir="5400000" rotWithShape="0">
               <a:srgbClr val="6A00C9">
@@ -15762,7 +15727,6 @@
           <a:ln>
             <a:noFill/>
           </a:ln>
-          <a:effectLst/>
           <a:effectLst>
             <a:outerShdw blurRad="95000" dist="38000" dir="5400000" rotWithShape="0">
               <a:srgbClr val="6A00C9">
@@ -16533,7 +16497,6 @@
           <a:ln>
             <a:noFill/>
           </a:ln>
-          <a:effectLst/>
           <a:effectLst>
             <a:outerShdw blurRad="95000" dist="38000" dir="5400000" rotWithShape="0">
               <a:srgbClr val="6A00C9">
@@ -16749,7 +16712,6 @@
           <a:ln>
             <a:noFill/>
           </a:ln>
-          <a:effectLst/>
           <a:effectLst>
             <a:outerShdw blurRad="95000" dist="38000" dir="5400000" rotWithShape="0">
               <a:srgbClr val="6A00C9">
@@ -16965,7 +16927,6 @@
           <a:ln>
             <a:noFill/>
           </a:ln>
-          <a:effectLst/>
           <a:effectLst>
             <a:outerShdw blurRad="95000" dist="38000" dir="5400000" rotWithShape="0">
               <a:srgbClr val="6A00C9">
@@ -17550,7 +17511,6 @@
           <a:ln>
             <a:noFill/>
           </a:ln>
-          <a:effectLst/>
           <a:effectLst>
             <a:outerShdw blurRad="95000" dist="38000" dir="5400000" rotWithShape="0">
               <a:srgbClr val="6A00C9">
@@ -17758,7 +17718,6 @@
           <a:ln>
             <a:noFill/>
           </a:ln>
-          <a:effectLst/>
           <a:effectLst>
             <a:outerShdw blurRad="95000" dist="38000" dir="5400000" rotWithShape="0">
               <a:srgbClr val="6A00C9">
@@ -17966,7 +17925,6 @@
           <a:ln>
             <a:noFill/>
           </a:ln>
-          <a:effectLst/>
           <a:effectLst>
             <a:outerShdw blurRad="95000" dist="38000" dir="5400000" rotWithShape="0">
               <a:srgbClr val="6A00C9">
@@ -18174,7 +18132,6 @@
           <a:ln>
             <a:noFill/>
           </a:ln>
-          <a:effectLst/>
           <a:effectLst>
             <a:outerShdw blurRad="95000" dist="38000" dir="5400000" rotWithShape="0">
               <a:srgbClr val="6A00C9">
@@ -20725,7 +20682,6 @@
           <a:ln>
             <a:noFill/>
           </a:ln>
-          <a:effectLst/>
           <a:effectLst>
             <a:outerShdw blurRad="95000" dist="38000" dir="5400000" rotWithShape="0">
               <a:srgbClr val="6A00C9">
@@ -21081,7 +21037,6 @@
           <a:ln>
             <a:noFill/>
           </a:ln>
-          <a:effectLst/>
           <a:effectLst>
             <a:outerShdw blurRad="95000" dist="38000" dir="5400000" rotWithShape="0">
               <a:srgbClr val="6A00C9">
@@ -21437,7 +21392,6 @@
           <a:ln>
             <a:noFill/>
           </a:ln>
-          <a:effectLst/>
           <a:effectLst>
             <a:outerShdw blurRad="95000" dist="38000" dir="5400000" rotWithShape="0">
               <a:srgbClr val="6A00C9">
@@ -21793,7 +21747,6 @@
           <a:ln>
             <a:noFill/>
           </a:ln>
-          <a:effectLst/>
           <a:effectLst>
             <a:outerShdw blurRad="95000" dist="38000" dir="5400000" rotWithShape="0">
               <a:srgbClr val="6A00C9">
@@ -22149,7 +22102,6 @@
           <a:ln>
             <a:noFill/>
           </a:ln>
-          <a:effectLst/>
           <a:effectLst>
             <a:outerShdw blurRad="95000" dist="38000" dir="5400000" rotWithShape="0">
               <a:srgbClr val="6A00C9">
@@ -22505,7 +22457,6 @@
           <a:ln>
             <a:noFill/>
           </a:ln>
-          <a:effectLst/>
           <a:effectLst>
             <a:outerShdw blurRad="95000" dist="38000" dir="5400000" rotWithShape="0">
               <a:srgbClr val="6A00C9">
@@ -25951,7 +25902,6 @@
           <a:ln>
             <a:noFill/>
           </a:ln>
-          <a:effectLst/>
           <a:effectLst>
             <a:outerShdw blurRad="95000" dist="38000" dir="5400000" rotWithShape="0">
               <a:srgbClr val="6A00C9">
@@ -26157,7 +26107,6 @@
           <a:ln>
             <a:noFill/>
           </a:ln>
-          <a:effectLst/>
           <a:effectLst>
             <a:outerShdw blurRad="95000" dist="38000" dir="5400000" rotWithShape="0">
               <a:srgbClr val="6A00C9">
@@ -26363,7 +26312,6 @@
           <a:ln>
             <a:noFill/>
           </a:ln>
-          <a:effectLst/>
           <a:effectLst>
             <a:outerShdw blurRad="95000" dist="38000" dir="5400000" rotWithShape="0">
               <a:srgbClr val="6A00C9">
@@ -26569,7 +26517,6 @@
           <a:ln>
             <a:noFill/>
           </a:ln>
-          <a:effectLst/>
           <a:effectLst>
             <a:outerShdw blurRad="95000" dist="38000" dir="5400000" rotWithShape="0">
               <a:srgbClr val="6A00C9">
@@ -26786,7 +26733,6 @@
           <a:ln>
             <a:noFill/>
           </a:ln>
-          <a:effectLst/>
           <a:effectLst>
             <a:outerShdw blurRad="95000" dist="38000" dir="5400000" rotWithShape="0">
               <a:srgbClr val="6A00C9">
@@ -27756,7 +27702,6 @@
           <a:ln>
             <a:noFill/>
           </a:ln>
-          <a:effectLst/>
           <a:effectLst>
             <a:outerShdw blurRad="95000" dist="38000" dir="5400000" rotWithShape="0">
               <a:srgbClr val="6A00C9">
@@ -27964,7 +27909,6 @@
           <a:ln>
             <a:noFill/>
           </a:ln>
-          <a:effectLst/>
           <a:effectLst>
             <a:outerShdw blurRad="95000" dist="38000" dir="5400000" rotWithShape="0">
               <a:srgbClr val="6A00C9">
@@ -28172,7 +28116,6 @@
           <a:ln>
             <a:noFill/>
           </a:ln>
-          <a:effectLst/>
           <a:effectLst>
             <a:outerShdw blurRad="95000" dist="38000" dir="5400000" rotWithShape="0">
               <a:srgbClr val="6A00C9">
@@ -28380,7 +28323,6 @@
           <a:ln>
             <a:noFill/>
           </a:ln>
-          <a:effectLst/>
           <a:effectLst>
             <a:outerShdw blurRad="95000" dist="38000" dir="5400000" rotWithShape="0">
               <a:srgbClr val="6A00C9">
@@ -30500,7 +30442,6 @@
           <a:ln>
             <a:noFill/>
           </a:ln>
-          <a:effectLst/>
           <a:effectLst>
             <a:outerShdw blurRad="95000" dist="38000" dir="5400000" rotWithShape="0">
               <a:srgbClr val="6A00C9">
@@ -31176,7 +31117,6 @@
           <a:ln>
             <a:noFill/>
           </a:ln>
-          <a:effectLst/>
           <a:effectLst>
             <a:outerShdw blurRad="95000" dist="38000" dir="5400000" rotWithShape="0">
               <a:srgbClr val="6A00C9">
@@ -31462,7 +31402,6 @@
           <a:ln>
             <a:noFill/>
           </a:ln>
-          <a:effectLst/>
           <a:effectLst>
             <a:outerShdw blurRad="95000" dist="38000" dir="5400000" rotWithShape="0">
               <a:srgbClr val="6A00C9">
@@ -31748,7 +31687,6 @@
           <a:ln>
             <a:noFill/>
           </a:ln>
-          <a:effectLst/>
           <a:effectLst>
             <a:outerShdw blurRad="95000" dist="38000" dir="5400000" rotWithShape="0">
               <a:srgbClr val="6A00C9">
@@ -32034,7 +31972,6 @@
           <a:ln>
             <a:noFill/>
           </a:ln>
-          <a:effectLst/>
           <a:effectLst>
             <a:outerShdw blurRad="95000" dist="38000" dir="5400000" rotWithShape="0">
               <a:srgbClr val="6A00C9">
@@ -33061,7 +32998,6 @@
           <a:ln>
             <a:noFill/>
           </a:ln>
-          <a:effectLst/>
           <a:effectLst>
             <a:outerShdw blurRad="95000" dist="38000" dir="5400000" rotWithShape="0">
               <a:srgbClr val="6A00C9">
@@ -33227,7 +33163,6 @@
           <a:ln>
             <a:noFill/>
           </a:ln>
-          <a:effectLst/>
           <a:effectLst>
             <a:outerShdw blurRad="95000" dist="38000" dir="5400000" rotWithShape="0">
               <a:srgbClr val="6A00C9">
@@ -33393,7 +33328,6 @@
           <a:ln>
             <a:noFill/>
           </a:ln>
-          <a:effectLst/>
           <a:effectLst>
             <a:outerShdw blurRad="95000" dist="38000" dir="5400000" rotWithShape="0">
               <a:srgbClr val="6A00C9">
@@ -33559,7 +33493,6 @@
           <a:ln>
             <a:noFill/>
           </a:ln>
-          <a:effectLst/>
           <a:effectLst>
             <a:outerShdw blurRad="95000" dist="38000" dir="5400000" rotWithShape="0">
               <a:srgbClr val="6A00C9">
@@ -33682,7 +33615,6 @@
           <a:ln>
             <a:noFill/>
           </a:ln>
-          <a:effectLst/>
           <a:effectLst>
             <a:outerShdw blurRad="95000" dist="38000" dir="5400000" rotWithShape="0">
               <a:srgbClr val="6A00C9">
@@ -33934,7 +33866,6 @@
           <a:ln>
             <a:noFill/>
           </a:ln>
-          <a:effectLst/>
           <a:effectLst>
             <a:outerShdw blurRad="95000" dist="38000" dir="5400000" rotWithShape="0">
               <a:srgbClr val="6A00C9">
@@ -34555,7 +34486,6 @@
           <a:ln>
             <a:noFill/>
           </a:ln>
-          <a:effectLst/>
           <a:effectLst>
             <a:outerShdw blurRad="95000" dist="38000" dir="5400000" rotWithShape="0">
               <a:srgbClr val="6A00C9">
@@ -34842,7 +34772,6 @@
           <a:ln>
             <a:noFill/>
           </a:ln>
-          <a:effectLst/>
           <a:effectLst>
             <a:outerShdw blurRad="95000" dist="38000" dir="5400000" rotWithShape="0">
               <a:srgbClr val="6A00C9">
@@ -35129,7 +35058,6 @@
           <a:ln>
             <a:noFill/>
           </a:ln>
-          <a:effectLst/>
           <a:effectLst>
             <a:outerShdw blurRad="95000" dist="38000" dir="5400000" rotWithShape="0">
               <a:srgbClr val="6A00C9">
@@ -35416,7 +35344,6 @@
           <a:ln>
             <a:noFill/>
           </a:ln>
-          <a:effectLst/>
           <a:effectLst>
             <a:outerShdw blurRad="95000" dist="38000" dir="5400000" rotWithShape="0">
               <a:srgbClr val="6A00C9">
@@ -35703,7 +35630,6 @@
           <a:ln>
             <a:noFill/>
           </a:ln>
-          <a:effectLst/>
           <a:effectLst>
             <a:outerShdw blurRad="95000" dist="38000" dir="5400000" rotWithShape="0">
               <a:srgbClr val="6A00C9">
@@ -35990,7 +35916,6 @@
           <a:ln>
             <a:noFill/>
           </a:ln>
-          <a:effectLst/>
           <a:effectLst>
             <a:outerShdw blurRad="95000" dist="38000" dir="5400000" rotWithShape="0">
               <a:srgbClr val="6A00C9">

</xml_diff>